<commit_message>
Add presentation deck: Tesla Integrity Bot Business Proposal PPTX
</commit_message>
<xml_diff>
--- a/tesla_rag/Tesla_Integrity_Bot_Business_Proposal_Final.pptx
+++ b/tesla_rag/Tesla_Integrity_Bot_Business_Proposal_Final.pptx
@@ -5,7 +5,7 @@
     <p:sldMasterId id="2147483648" r:id="rId1"/>
   </p:sldMasterIdLst>
   <p:notesMasterIdLst>
-    <p:notesMasterId r:id="rId12"/>
+    <p:notesMasterId r:id="rId13"/>
   </p:notesMasterIdLst>
   <p:sldIdLst>
     <p:sldId id="267" r:id="rId2"/>
@@ -18,6 +18,7 @@
     <p:sldId id="262" r:id="rId9"/>
     <p:sldId id="263" r:id="rId10"/>
     <p:sldId id="265" r:id="rId11"/>
+    <p:sldId id="268" r:id="rId12"/>
   </p:sldIdLst>
   <p:sldSz cx="12192000" cy="6858000"/>
   <p:notesSz cx="6858000" cy="9144000"/>
@@ -1113,6 +1114,103 @@
 </p:notes>
 </file>
 
+<file path=ppt/notesSlides/notesSlide11.xml><?xml version="1.0" encoding="utf-8"?>
+<p:notes xmlns:a="http://schemas.openxmlformats.org/drawingml/2006/main" xmlns:r="http://schemas.openxmlformats.org/officeDocument/2006/relationships" xmlns:p="http://schemas.openxmlformats.org/presentationml/2006/main">
+  <p:cSld>
+    <p:spTree>
+      <p:nvGrpSpPr>
+        <p:cNvPr id="1" name="">
+          <a:extLst>
+            <a:ext uri="{FF2B5EF4-FFF2-40B4-BE49-F238E27FC236}">
+              <a16:creationId xmlns:a16="http://schemas.microsoft.com/office/drawing/2014/main" id="{DE7AA7AB-F9B8-C44C-7333-AA750E0090C0}"/>
+            </a:ext>
+          </a:extLst>
+        </p:cNvPr>
+        <p:cNvGrpSpPr/>
+        <p:nvPr/>
+      </p:nvGrpSpPr>
+      <p:grpSpPr>
+        <a:xfrm>
+          <a:off x="0" y="0"/>
+          <a:ext cx="0" cy="0"/>
+          <a:chOff x="0" y="0"/>
+          <a:chExt cx="0" cy="0"/>
+        </a:xfrm>
+      </p:grpSpPr>
+      <p:sp>
+        <p:nvSpPr>
+          <p:cNvPr id="2" name="Slide Image Placeholder 1">
+            <a:extLst>
+              <a:ext uri="{FF2B5EF4-FFF2-40B4-BE49-F238E27FC236}">
+                <a16:creationId xmlns:a16="http://schemas.microsoft.com/office/drawing/2014/main" id="{3CA0E243-4257-0D24-43FF-B2ABB424732C}"/>
+              </a:ext>
+            </a:extLst>
+          </p:cNvPr>
+          <p:cNvSpPr>
+            <a:spLocks noGrp="1" noRot="1" noChangeAspect="1"/>
+          </p:cNvSpPr>
+          <p:nvPr>
+            <p:ph type="sldImg" idx="2"/>
+          </p:nvPr>
+        </p:nvSpPr>
+        <p:spPr/>
+      </p:sp>
+      <p:sp>
+        <p:nvSpPr>
+          <p:cNvPr id="3" name="Notes Placeholder 2">
+            <a:extLst>
+              <a:ext uri="{FF2B5EF4-FFF2-40B4-BE49-F238E27FC236}">
+                <a16:creationId xmlns:a16="http://schemas.microsoft.com/office/drawing/2014/main" id="{2E852AEE-7B97-6AB6-2939-B21781E9DBA0}"/>
+              </a:ext>
+            </a:extLst>
+          </p:cNvPr>
+          <p:cNvSpPr>
+            <a:spLocks noGrp="1"/>
+          </p:cNvSpPr>
+          <p:nvPr>
+            <p:ph type="body" sz="quarter" idx="3"/>
+          </p:nvPr>
+        </p:nvSpPr>
+        <p:spPr/>
+        <p:txBody>
+          <a:bodyPr/>
+          <a:lstStyle/>
+          <a:p>
+            <a:endParaRPr dirty="0"/>
+          </a:p>
+        </p:txBody>
+      </p:sp>
+      <p:sp>
+        <p:nvSpPr>
+          <p:cNvPr id="4" name="Slide Number Placeholder 3">
+            <a:extLst>
+              <a:ext uri="{FF2B5EF4-FFF2-40B4-BE49-F238E27FC236}">
+                <a16:creationId xmlns:a16="http://schemas.microsoft.com/office/drawing/2014/main" id="{08D2DAE9-F165-B551-5A9B-14D8114DDFE0}"/>
+              </a:ext>
+            </a:extLst>
+          </p:cNvPr>
+          <p:cNvSpPr>
+            <a:spLocks noGrp="1"/>
+          </p:cNvSpPr>
+          <p:nvPr>
+            <p:ph type="sldNum" sz="quarter" idx="5"/>
+          </p:nvPr>
+        </p:nvSpPr>
+        <p:spPr/>
+      </p:sp>
+    </p:spTree>
+    <p:extLst>
+      <p:ext uri="{BB962C8B-B14F-4D97-AF65-F5344CB8AC3E}">
+        <p14:creationId xmlns:p14="http://schemas.microsoft.com/office/powerpoint/2010/main" val="1884201839"/>
+      </p:ext>
+    </p:extLst>
+  </p:cSld>
+  <p:clrMapOvr>
+    <a:masterClrMapping/>
+  </p:clrMapOvr>
+</p:notes>
+</file>
+
 <file path=ppt/notesSlides/notesSlide2.xml><?xml version="1.0" encoding="utf-8"?>
 <p:notes xmlns:a="http://schemas.openxmlformats.org/drawingml/2006/main" xmlns:r="http://schemas.openxmlformats.org/officeDocument/2006/relationships" xmlns:p="http://schemas.openxmlformats.org/presentationml/2006/main">
   <p:cSld>
@@ -4738,51 +4836,6 @@
       </p:sp>
       <p:sp>
         <p:nvSpPr>
-          <p:cNvPr id="21" name="TextBox 20">
-            <a:extLst>
-              <a:ext uri="{FF2B5EF4-FFF2-40B4-BE49-F238E27FC236}">
-                <a16:creationId xmlns:a16="http://schemas.microsoft.com/office/drawing/2014/main" id="{5BF02A16-2C3D-6CBF-C99B-440CBB257008}"/>
-              </a:ext>
-            </a:extLst>
-          </p:cNvPr>
-          <p:cNvSpPr txBox="1"/>
-          <p:nvPr/>
-        </p:nvSpPr>
-        <p:spPr>
-          <a:xfrm>
-            <a:off x="10698480" y="6428232"/>
-            <a:ext cx="941832" cy="256032"/>
-          </a:xfrm>
-          <a:prstGeom prst="rect">
-            <a:avLst/>
-          </a:prstGeom>
-          <a:noFill/>
-        </p:spPr>
-        <p:txBody>
-          <a:bodyPr wrap="square" lIns="0" tIns="0" rIns="0" bIns="0" anchor="t">
-            <a:spAutoFit/>
-          </a:bodyPr>
-          <a:lstStyle/>
-          <a:p>
-            <a:pPr algn="r">
-              <a:spcAft>
-                <a:spcPts val="0"/>
-              </a:spcAft>
-            </a:pPr>
-            <a:r>
-              <a:rPr sz="1000" b="0" i="0">
-                <a:solidFill>
-                  <a:srgbClr val="8A8A8A"/>
-                </a:solidFill>
-                <a:latin typeface="Arial"/>
-              </a:rPr>
-              <a:t>1 / 11</a:t>
-            </a:r>
-          </a:p>
-        </p:txBody>
-      </p:sp>
-      <p:sp>
-        <p:nvSpPr>
           <p:cNvPr id="20" name="Benefit card 1">
             <a:extLst>
               <a:ext uri="{FF2B5EF4-FFF2-40B4-BE49-F238E27FC236}">
@@ -4795,7 +4848,7 @@
         </p:nvSpPr>
         <p:spPr>
           <a:xfrm>
-            <a:off x="1592981" y="3929897"/>
+            <a:off x="1592981" y="3939041"/>
             <a:ext cx="9654139" cy="1371600"/>
           </a:xfrm>
           <a:prstGeom prst="roundRect">
@@ -4953,45 +5006,6 @@
       </p:sp>
       <p:sp>
         <p:nvSpPr>
-          <p:cNvPr id="5" name="Slide number"/>
-          <p:cNvSpPr txBox="1"/>
-          <p:nvPr/>
-        </p:nvSpPr>
-        <p:spPr>
-          <a:xfrm>
-            <a:off x="10698480" y="6428232"/>
-            <a:ext cx="941832" cy="256032"/>
-          </a:xfrm>
-          <a:prstGeom prst="rect">
-            <a:avLst/>
-          </a:prstGeom>
-          <a:noFill/>
-        </p:spPr>
-        <p:txBody>
-          <a:bodyPr wrap="square" lIns="0" tIns="0" rIns="0" bIns="0" anchor="t">
-            <a:spAutoFit/>
-          </a:bodyPr>
-          <a:lstStyle/>
-          <a:p>
-            <a:pPr algn="r">
-              <a:spcAft>
-                <a:spcPts val="0"/>
-              </a:spcAft>
-            </a:pPr>
-            <a:r>
-              <a:rPr sz="1000" b="0" i="0">
-                <a:solidFill>
-                  <a:srgbClr val="8A8A8A"/>
-                </a:solidFill>
-                <a:latin typeface="Arial"/>
-              </a:rPr>
-              <a:t>10 / 11</a:t>
-            </a:r>
-          </a:p>
-        </p:txBody>
-      </p:sp>
-      <p:sp>
-        <p:nvSpPr>
           <p:cNvPr id="6" name="Frame Grounded answer with source badge"/>
           <p:cNvSpPr/>
           <p:nvPr/>
@@ -5522,6 +5536,115 @@
         </p:txBody>
       </p:sp>
     </p:spTree>
+  </p:cSld>
+  <p:clrMapOvr>
+    <a:masterClrMapping/>
+  </p:clrMapOvr>
+</p:sld>
+</file>
+
+<file path=ppt/slides/slide11.xml><?xml version="1.0" encoding="utf-8"?>
+<p:sld xmlns:a="http://schemas.openxmlformats.org/drawingml/2006/main" xmlns:r="http://schemas.openxmlformats.org/officeDocument/2006/relationships" xmlns:p="http://schemas.openxmlformats.org/presentationml/2006/main">
+  <p:cSld>
+    <p:bg>
+      <p:bgPr>
+        <a:solidFill>
+          <a:srgbClr val="0B0B0B"/>
+        </a:solidFill>
+        <a:effectLst/>
+      </p:bgPr>
+    </p:bg>
+    <p:spTree>
+      <p:nvGrpSpPr>
+        <p:cNvPr id="1" name="">
+          <a:extLst>
+            <a:ext uri="{FF2B5EF4-FFF2-40B4-BE49-F238E27FC236}">
+              <a16:creationId xmlns:a16="http://schemas.microsoft.com/office/drawing/2014/main" id="{24FDA91D-4E95-D7E3-430C-222D5031AA48}"/>
+            </a:ext>
+          </a:extLst>
+        </p:cNvPr>
+        <p:cNvGrpSpPr/>
+        <p:nvPr/>
+      </p:nvGrpSpPr>
+      <p:grpSpPr>
+        <a:xfrm>
+          <a:off x="0" y="0"/>
+          <a:ext cx="0" cy="0"/>
+          <a:chOff x="0" y="0"/>
+          <a:chExt cx="0" cy="0"/>
+        </a:xfrm>
+      </p:grpSpPr>
+      <p:sp>
+        <p:nvSpPr>
+          <p:cNvPr id="3" name="Title">
+            <a:extLst>
+              <a:ext uri="{FF2B5EF4-FFF2-40B4-BE49-F238E27FC236}">
+                <a16:creationId xmlns:a16="http://schemas.microsoft.com/office/drawing/2014/main" id="{C7C91E67-15BF-3FD6-247C-3177833F0F99}"/>
+              </a:ext>
+            </a:extLst>
+          </p:cNvPr>
+          <p:cNvSpPr txBox="1"/>
+          <p:nvPr/>
+        </p:nvSpPr>
+        <p:spPr>
+          <a:xfrm>
+            <a:off x="731520" y="1143000"/>
+            <a:ext cx="10515600" cy="2677656"/>
+          </a:xfrm>
+          <a:prstGeom prst="rect">
+            <a:avLst/>
+          </a:prstGeom>
+          <a:noFill/>
+        </p:spPr>
+        <p:txBody>
+          <a:bodyPr wrap="square" lIns="0" tIns="0" rIns="0" bIns="0" anchor="t">
+            <a:spAutoFit/>
+          </a:bodyPr>
+          <a:lstStyle/>
+          <a:p>
+            <a:r>
+              <a:rPr lang="en-IN" sz="5800" b="1" dirty="0">
+                <a:solidFill>
+                  <a:srgbClr val="FFFFFF"/>
+                </a:solidFill>
+                <a:latin typeface="Arial"/>
+              </a:rPr>
+              <a:t>              </a:t>
+            </a:r>
+          </a:p>
+          <a:p>
+            <a:endParaRPr lang="en-IN" sz="5800" b="1" dirty="0">
+              <a:solidFill>
+                <a:srgbClr val="FFFFFF"/>
+              </a:solidFill>
+              <a:latin typeface="Arial"/>
+            </a:endParaRPr>
+          </a:p>
+          <a:p>
+            <a:r>
+              <a:rPr lang="en-IN" sz="5800" b="1" dirty="0">
+                <a:solidFill>
+                  <a:srgbClr val="FFFFFF"/>
+                </a:solidFill>
+                <a:latin typeface="Arial"/>
+              </a:rPr>
+              <a:t>                Thank You</a:t>
+            </a:r>
+            <a:endParaRPr sz="4000" b="1" i="0" dirty="0">
+              <a:solidFill>
+                <a:srgbClr val="FFFFFF"/>
+              </a:solidFill>
+              <a:latin typeface="Arial"/>
+            </a:endParaRPr>
+          </a:p>
+        </p:txBody>
+      </p:sp>
+    </p:spTree>
+    <p:extLst>
+      <p:ext uri="{BB962C8B-B14F-4D97-AF65-F5344CB8AC3E}">
+        <p14:creationId xmlns:p14="http://schemas.microsoft.com/office/powerpoint/2010/main" val="4141557376"/>
+      </p:ext>
+    </p:extLst>
   </p:cSld>
   <p:clrMapOvr>
     <a:masterClrMapping/>
@@ -6270,45 +6393,6 @@
                 <a:latin typeface="Arial"/>
               </a:rPr>
               <a:t>Every answer links to its source</a:t>
-            </a:r>
-          </a:p>
-        </p:txBody>
-      </p:sp>
-      <p:sp>
-        <p:nvSpPr>
-          <p:cNvPr id="21" name="TextBox 20"/>
-          <p:cNvSpPr txBox="1"/>
-          <p:nvPr/>
-        </p:nvSpPr>
-        <p:spPr>
-          <a:xfrm>
-            <a:off x="10698480" y="6428232"/>
-            <a:ext cx="941832" cy="256032"/>
-          </a:xfrm>
-          <a:prstGeom prst="rect">
-            <a:avLst/>
-          </a:prstGeom>
-          <a:noFill/>
-        </p:spPr>
-        <p:txBody>
-          <a:bodyPr wrap="square" lIns="0" tIns="0" rIns="0" bIns="0" anchor="t">
-            <a:spAutoFit/>
-          </a:bodyPr>
-          <a:lstStyle/>
-          <a:p>
-            <a:pPr algn="r">
-              <a:spcAft>
-                <a:spcPts val="0"/>
-              </a:spcAft>
-            </a:pPr>
-            <a:r>
-              <a:rPr sz="1000" b="0" i="0">
-                <a:solidFill>
-                  <a:srgbClr val="8A8A8A"/>
-                </a:solidFill>
-                <a:latin typeface="Arial"/>
-              </a:rPr>
-              <a:t>1 / 11</a:t>
             </a:r>
           </a:p>
         </p:txBody>
@@ -6387,45 +6471,6 @@
       </p:sp>
       <p:sp>
         <p:nvSpPr>
-          <p:cNvPr id="5" name="Slide number"/>
-          <p:cNvSpPr txBox="1"/>
-          <p:nvPr/>
-        </p:nvSpPr>
-        <p:spPr>
-          <a:xfrm>
-            <a:off x="10698480" y="6428232"/>
-            <a:ext cx="941832" cy="256032"/>
-          </a:xfrm>
-          <a:prstGeom prst="rect">
-            <a:avLst/>
-          </a:prstGeom>
-          <a:noFill/>
-        </p:spPr>
-        <p:txBody>
-          <a:bodyPr wrap="square" lIns="0" tIns="0" rIns="0" bIns="0" anchor="t">
-            <a:spAutoFit/>
-          </a:bodyPr>
-          <a:lstStyle/>
-          <a:p>
-            <a:pPr algn="r">
-              <a:spcAft>
-                <a:spcPts val="0"/>
-              </a:spcAft>
-            </a:pPr>
-            <a:r>
-              <a:rPr sz="1000" b="0" i="0">
-                <a:solidFill>
-                  <a:srgbClr val="8A8A8A"/>
-                </a:solidFill>
-                <a:latin typeface="Arial"/>
-              </a:rPr>
-              <a:t>2 / 11</a:t>
-            </a:r>
-          </a:p>
-        </p:txBody>
-      </p:sp>
-      <p:sp>
-        <p:nvSpPr>
           <p:cNvPr id="6" name="TextBox 5"/>
           <p:cNvSpPr txBox="1"/>
           <p:nvPr/>
@@ -7445,7 +7490,7 @@
               </a:spcAft>
             </a:pPr>
             <a:r>
-              <a:rPr sz="1700" b="1" i="0">
+              <a:rPr sz="1700" b="1" i="0" dirty="0">
                 <a:solidFill>
                   <a:srgbClr val="FFFFFF"/>
                 </a:solidFill>
@@ -7683,45 +7728,6 @@
       </p:sp>
       <p:sp>
         <p:nvSpPr>
-          <p:cNvPr id="5" name="Slide number"/>
-          <p:cNvSpPr txBox="1"/>
-          <p:nvPr/>
-        </p:nvSpPr>
-        <p:spPr>
-          <a:xfrm>
-            <a:off x="10698480" y="6428232"/>
-            <a:ext cx="941832" cy="256032"/>
-          </a:xfrm>
-          <a:prstGeom prst="rect">
-            <a:avLst/>
-          </a:prstGeom>
-          <a:noFill/>
-        </p:spPr>
-        <p:txBody>
-          <a:bodyPr wrap="square" lIns="0" tIns="0" rIns="0" bIns="0" anchor="t">
-            <a:spAutoFit/>
-          </a:bodyPr>
-          <a:lstStyle/>
-          <a:p>
-            <a:pPr algn="r">
-              <a:spcAft>
-                <a:spcPts val="0"/>
-              </a:spcAft>
-            </a:pPr>
-            <a:r>
-              <a:rPr sz="1000" b="0" i="0">
-                <a:solidFill>
-                  <a:srgbClr val="8A8A8A"/>
-                </a:solidFill>
-                <a:latin typeface="Arial"/>
-              </a:rPr>
-              <a:t>3 / 11</a:t>
-            </a:r>
-          </a:p>
-        </p:txBody>
-      </p:sp>
-      <p:sp>
-        <p:nvSpPr>
           <p:cNvPr id="6" name="Oval 5"/>
           <p:cNvSpPr/>
           <p:nvPr/>
@@ -8824,45 +8830,6 @@
       </p:sp>
       <p:sp>
         <p:nvSpPr>
-          <p:cNvPr id="5" name="Slide number"/>
-          <p:cNvSpPr txBox="1"/>
-          <p:nvPr/>
-        </p:nvSpPr>
-        <p:spPr>
-          <a:xfrm>
-            <a:off x="10698480" y="6428232"/>
-            <a:ext cx="941832" cy="256032"/>
-          </a:xfrm>
-          <a:prstGeom prst="rect">
-            <a:avLst/>
-          </a:prstGeom>
-          <a:noFill/>
-        </p:spPr>
-        <p:txBody>
-          <a:bodyPr wrap="square" lIns="0" tIns="0" rIns="0" bIns="0" anchor="t">
-            <a:spAutoFit/>
-          </a:bodyPr>
-          <a:lstStyle/>
-          <a:p>
-            <a:pPr algn="r">
-              <a:spcAft>
-                <a:spcPts val="0"/>
-              </a:spcAft>
-            </a:pPr>
-            <a:r>
-              <a:rPr sz="1000" b="0" i="0">
-                <a:solidFill>
-                  <a:srgbClr val="8A8A8A"/>
-                </a:solidFill>
-                <a:latin typeface="Arial"/>
-              </a:rPr>
-              <a:t>4 / 11</a:t>
-            </a:r>
-          </a:p>
-        </p:txBody>
-      </p:sp>
-      <p:sp>
-        <p:nvSpPr>
           <p:cNvPr id="6" name="User card 1"/>
           <p:cNvSpPr/>
           <p:nvPr/>
@@ -9729,7 +9696,7 @@
               </a:spcAft>
             </a:pPr>
             <a:r>
-              <a:rPr sz="1400" b="0" i="0">
+              <a:rPr sz="1400" b="0" i="0" dirty="0">
                 <a:solidFill>
                   <a:srgbClr val="555555"/>
                 </a:solidFill>
@@ -10130,23 +10097,8 @@
                 </a:solidFill>
                 <a:latin typeface="Arial"/>
               </a:rPr>
-              <a:t> chat UI, source badges, </a:t>
-            </a:r>
-            <a:r>
-              <a:rPr sz="1300" b="0" i="0">
-                <a:solidFill>
-                  <a:srgbClr val="171717"/>
-                </a:solidFill>
-                <a:latin typeface="Arial"/>
-              </a:rPr>
-              <a:t>chunk inspector.</a:t>
-            </a:r>
-            <a:endParaRPr sz="1300" b="0" i="0" dirty="0">
-              <a:solidFill>
-                <a:srgbClr val="171717"/>
-              </a:solidFill>
-              <a:latin typeface="Arial"/>
-            </a:endParaRPr>
+              <a:t> chat UI, source badges, chunk inspector.</a:t>
+            </a:r>
           </a:p>
         </p:txBody>
       </p:sp>
@@ -10224,84 +10176,6 @@
       </p:sp>
       <p:sp>
         <p:nvSpPr>
-          <p:cNvPr id="4" name="Footer"/>
-          <p:cNvSpPr txBox="1"/>
-          <p:nvPr/>
-        </p:nvSpPr>
-        <p:spPr>
-          <a:xfrm>
-            <a:off x="548640" y="6428232"/>
-            <a:ext cx="8686800" cy="153888"/>
-          </a:xfrm>
-          <a:prstGeom prst="rect">
-            <a:avLst/>
-          </a:prstGeom>
-          <a:noFill/>
-        </p:spPr>
-        <p:txBody>
-          <a:bodyPr wrap="square" lIns="0" tIns="0" rIns="0" bIns="0" anchor="t">
-            <a:spAutoFit/>
-          </a:bodyPr>
-          <a:lstStyle/>
-          <a:p>
-            <a:pPr algn="l">
-              <a:spcAft>
-                <a:spcPts val="0"/>
-              </a:spcAft>
-            </a:pPr>
-            <a:r>
-              <a:rPr sz="1000" b="0" i="0" dirty="0">
-                <a:solidFill>
-                  <a:srgbClr val="8A8A8A"/>
-                </a:solidFill>
-                <a:latin typeface="Arial"/>
-              </a:rPr>
-              <a:t>.</a:t>
-            </a:r>
-          </a:p>
-        </p:txBody>
-      </p:sp>
-      <p:sp>
-        <p:nvSpPr>
-          <p:cNvPr id="5" name="Slide number"/>
-          <p:cNvSpPr txBox="1"/>
-          <p:nvPr/>
-        </p:nvSpPr>
-        <p:spPr>
-          <a:xfrm>
-            <a:off x="10698480" y="6428232"/>
-            <a:ext cx="941832" cy="256032"/>
-          </a:xfrm>
-          <a:prstGeom prst="rect">
-            <a:avLst/>
-          </a:prstGeom>
-          <a:noFill/>
-        </p:spPr>
-        <p:txBody>
-          <a:bodyPr wrap="square" lIns="0" tIns="0" rIns="0" bIns="0" anchor="t">
-            <a:spAutoFit/>
-          </a:bodyPr>
-          <a:lstStyle/>
-          <a:p>
-            <a:pPr algn="r">
-              <a:spcAft>
-                <a:spcPts val="0"/>
-              </a:spcAft>
-            </a:pPr>
-            <a:r>
-              <a:rPr sz="1000" b="0" i="0">
-                <a:solidFill>
-                  <a:srgbClr val="8A8A8A"/>
-                </a:solidFill>
-                <a:latin typeface="Arial"/>
-              </a:rPr>
-              <a:t>5 / 11</a:t>
-            </a:r>
-          </a:p>
-        </p:txBody>
-      </p:sp>
-      <p:sp>
-        <p:nvSpPr>
           <p:cNvPr id="6" name="Rectangle 5"/>
           <p:cNvSpPr/>
           <p:nvPr/>
@@ -11969,7 +11843,7 @@
               </a:spcAft>
             </a:pPr>
             <a:r>
-              <a:rPr sz="1400" b="1" i="0">
+              <a:rPr sz="1400" b="1" i="0" dirty="0">
                 <a:solidFill>
                   <a:srgbClr val="E31937"/>
                 </a:solidFill>
@@ -11978,7 +11852,7 @@
               <a:t>Trade-off: </a:t>
             </a:r>
             <a:r>
-              <a:rPr sz="1400" b="0" i="0">
+              <a:rPr sz="1400" b="0" i="0" dirty="0">
                 <a:solidFill>
                   <a:srgbClr val="FFFFFF"/>
                 </a:solidFill>
@@ -12090,45 +11964,6 @@
       </p:sp>
       <p:sp>
         <p:nvSpPr>
-          <p:cNvPr id="5" name="Slide number"/>
-          <p:cNvSpPr txBox="1"/>
-          <p:nvPr/>
-        </p:nvSpPr>
-        <p:spPr>
-          <a:xfrm>
-            <a:off x="10698480" y="6428232"/>
-            <a:ext cx="941832" cy="256032"/>
-          </a:xfrm>
-          <a:prstGeom prst="rect">
-            <a:avLst/>
-          </a:prstGeom>
-          <a:noFill/>
-        </p:spPr>
-        <p:txBody>
-          <a:bodyPr wrap="square" lIns="0" tIns="0" rIns="0" bIns="0" anchor="t">
-            <a:spAutoFit/>
-          </a:bodyPr>
-          <a:lstStyle/>
-          <a:p>
-            <a:pPr algn="r">
-              <a:spcAft>
-                <a:spcPts val="0"/>
-              </a:spcAft>
-            </a:pPr>
-            <a:r>
-              <a:rPr sz="1000" b="0" i="0">
-                <a:solidFill>
-                  <a:srgbClr val="8A8A8A"/>
-                </a:solidFill>
-                <a:latin typeface="Arial"/>
-              </a:rPr>
-              <a:t>6 / 11</a:t>
-            </a:r>
-          </a:p>
-        </p:txBody>
-      </p:sp>
-      <p:sp>
-        <p:nvSpPr>
           <p:cNvPr id="6" name="TextBox 5"/>
           <p:cNvSpPr txBox="1"/>
           <p:nvPr/>
@@ -14224,45 +14059,6 @@
                 <a:latin typeface="Arial"/>
               </a:rPr>
               <a:t>No hallucinations flagged across 15 test questions</a:t>
-            </a:r>
-          </a:p>
-        </p:txBody>
-      </p:sp>
-      <p:sp>
-        <p:nvSpPr>
-          <p:cNvPr id="5" name="Slide number"/>
-          <p:cNvSpPr txBox="1"/>
-          <p:nvPr/>
-        </p:nvSpPr>
-        <p:spPr>
-          <a:xfrm>
-            <a:off x="10698480" y="6428232"/>
-            <a:ext cx="941832" cy="256032"/>
-          </a:xfrm>
-          <a:prstGeom prst="rect">
-            <a:avLst/>
-          </a:prstGeom>
-          <a:noFill/>
-        </p:spPr>
-        <p:txBody>
-          <a:bodyPr wrap="square" lIns="0" tIns="0" rIns="0" bIns="0" anchor="t">
-            <a:spAutoFit/>
-          </a:bodyPr>
-          <a:lstStyle/>
-          <a:p>
-            <a:pPr algn="r">
-              <a:spcAft>
-                <a:spcPts val="0"/>
-              </a:spcAft>
-            </a:pPr>
-            <a:r>
-              <a:rPr sz="1000" b="0" i="0">
-                <a:solidFill>
-                  <a:srgbClr val="8A8A8A"/>
-                </a:solidFill>
-                <a:latin typeface="Arial"/>
-              </a:rPr>
-              <a:t>8 / 11</a:t>
             </a:r>
           </a:p>
         </p:txBody>

</xml_diff>